<commit_message>
Fix East Asian font handling and add the public usage guide
</commit_message>
<xml_diff>
--- a/skills/academic-ppt-craft/assets/visual-combinations.pptx
+++ b/skills/academic-ppt-craft/assets/visual-combinations.pptx
@@ -3894,6 +3894,10 @@
               </a:defRPr>
             </a:pPr>
             <a:r>
+              <a:rPr>
+                <a:ea typeface="Microsoft YaHei"/>
+                <a:cs typeface="Microsoft YaHei"/>
+              </a:rPr>
               <a:t>白底图名压住粗边框</a:t>
             </a:r>
           </a:p>
@@ -3930,6 +3934,10 @@
               </a:defRPr>
             </a:pPr>
             <a:r>
+              <a:rPr>
+                <a:ea typeface="Microsoft YaHei"/>
+                <a:cs typeface="Microsoft YaHei"/>
+              </a:rPr>
               <a:t>白底只遮住图名背后的边线；图、框、文字均可编辑。</a:t>
             </a:r>
           </a:p>
@@ -4009,6 +4017,10 @@
               </a:defRPr>
             </a:pPr>
             <a:r>
+              <a:rPr>
+                <a:ea typeface="Microsoft YaHei"/>
+                <a:cs typeface="Microsoft YaHei"/>
+              </a:rPr>
               <a:t>实验画面</a:t>
             </a:r>
           </a:p>
@@ -4090,6 +4102,10 @@
               </a:defRPr>
             </a:pPr>
             <a:r>
+              <a:rPr>
+                <a:ea typeface="Microsoft YaHei"/>
+                <a:cs typeface="Microsoft YaHei"/>
+              </a:rPr>
               <a:t>关键实验</a:t>
             </a:r>
           </a:p>
@@ -4144,6 +4160,10 @@
               </a:defRPr>
             </a:pPr>
             <a:r>
+              <a:rPr>
+                <a:ea typeface="Microsoft YaHei"/>
+                <a:cs typeface="Microsoft YaHei"/>
+              </a:rPr>
               <a:t>并列条件与共同外框</a:t>
             </a:r>
           </a:p>
@@ -4180,6 +4200,10 @@
               </a:defRPr>
             </a:pPr>
             <a:r>
+              <a:rPr>
+                <a:ea typeface="Microsoft YaHei"/>
+                <a:cs typeface="Microsoft YaHei"/>
+              </a:rPr>
               <a:t>同一任务的两个条件，保留相同尺度与对齐关系。</a:t>
             </a:r>
           </a:p>
@@ -4302,6 +4326,10 @@
               </a:defRPr>
             </a:pPr>
             <a:r>
+              <a:rPr>
+                <a:ea typeface="Microsoft YaHei"/>
+                <a:cs typeface="Microsoft YaHei"/>
+              </a:rPr>
               <a:t>实验画面</a:t>
             </a:r>
           </a:p>
@@ -4340,6 +4368,10 @@
               </a:defRPr>
             </a:pPr>
             <a:r>
+              <a:rPr>
+                <a:ea typeface="Microsoft YaHei"/>
+                <a:cs typeface="Microsoft YaHei"/>
+              </a:rPr>
               <a:t>条件 A</a:t>
             </a:r>
           </a:p>
@@ -4419,6 +4451,10 @@
               </a:defRPr>
             </a:pPr>
             <a:r>
+              <a:rPr>
+                <a:ea typeface="Microsoft YaHei"/>
+                <a:cs typeface="Microsoft YaHei"/>
+              </a:rPr>
               <a:t>实验画面</a:t>
             </a:r>
           </a:p>
@@ -4457,6 +4493,10 @@
               </a:defRPr>
             </a:pPr>
             <a:r>
+              <a:rPr>
+                <a:ea typeface="Microsoft YaHei"/>
+                <a:cs typeface="Microsoft YaHei"/>
+              </a:rPr>
               <a:t>条件 B</a:t>
             </a:r>
           </a:p>
@@ -4511,6 +4551,10 @@
               </a:defRPr>
             </a:pPr>
             <a:r>
+              <a:rPr>
+                <a:ea typeface="Microsoft YaHei"/>
+                <a:cs typeface="Microsoft YaHei"/>
+              </a:rPr>
               <a:t>角标与局部说明</a:t>
             </a:r>
           </a:p>
@@ -4547,6 +4591,10 @@
               </a:defRPr>
             </a:pPr>
             <a:r>
+              <a:rPr>
+                <a:ea typeface="Microsoft YaHei"/>
+                <a:cs typeface="Microsoft YaHei"/>
+              </a:rPr>
               <a:t>多个同类小图可以少用边框，靠角标和短标签组织。</a:t>
             </a:r>
           </a:p>
@@ -4626,6 +4674,10 @@
               </a:defRPr>
             </a:pPr>
             <a:r>
+              <a:rPr>
+                <a:ea typeface="Microsoft YaHei"/>
+                <a:cs typeface="Microsoft YaHei"/>
+              </a:rPr>
               <a:t>实验画面</a:t>
             </a:r>
           </a:p>
@@ -4748,6 +4800,10 @@
               </a:defRPr>
             </a:pPr>
             <a:r>
+              <a:rPr>
+                <a:ea typeface="Microsoft YaHei"/>
+                <a:cs typeface="Microsoft YaHei"/>
+              </a:rPr>
               <a:t>接触前</a:t>
             </a:r>
           </a:p>
@@ -4827,6 +4883,10 @@
               </a:defRPr>
             </a:pPr>
             <a:r>
+              <a:rPr>
+                <a:ea typeface="Microsoft YaHei"/>
+                <a:cs typeface="Microsoft YaHei"/>
+              </a:rPr>
               <a:t>实验画面</a:t>
             </a:r>
           </a:p>
@@ -4949,6 +5009,10 @@
               </a:defRPr>
             </a:pPr>
             <a:r>
+              <a:rPr>
+                <a:ea typeface="Microsoft YaHei"/>
+                <a:cs typeface="Microsoft YaHei"/>
+              </a:rPr>
               <a:t>接触建立</a:t>
             </a:r>
           </a:p>
@@ -5028,6 +5092,10 @@
               </a:defRPr>
             </a:pPr>
             <a:r>
+              <a:rPr>
+                <a:ea typeface="Microsoft YaHei"/>
+                <a:cs typeface="Microsoft YaHei"/>
+              </a:rPr>
               <a:t>实验画面</a:t>
             </a:r>
           </a:p>
@@ -5150,6 +5218,10 @@
               </a:defRPr>
             </a:pPr>
             <a:r>
+              <a:rPr>
+                <a:ea typeface="Microsoft YaHei"/>
+                <a:cs typeface="Microsoft YaHei"/>
+              </a:rPr>
               <a:t>接触变化</a:t>
             </a:r>
           </a:p>
@@ -5204,6 +5276,10 @@
               </a:defRPr>
             </a:pPr>
             <a:r>
+              <a:rPr>
+                <a:ea typeface="Microsoft YaHei"/>
+                <a:cs typeface="Microsoft YaHei"/>
+              </a:rPr>
               <a:t>侧边色线联系解释</a:t>
             </a:r>
           </a:p>
@@ -5240,6 +5316,10 @@
               </a:defRPr>
             </a:pPr>
             <a:r>
+              <a:rPr>
+                <a:ea typeface="Microsoft YaHei"/>
+                <a:cs typeface="Microsoft YaHei"/>
+              </a:rPr>
               <a:t>图侧说明对准图内对象，边线不绕整页一圈。</a:t>
             </a:r>
           </a:p>
@@ -5319,6 +5399,10 @@
               </a:defRPr>
             </a:pPr>
             <a:r>
+              <a:rPr>
+                <a:ea typeface="Microsoft YaHei"/>
+                <a:cs typeface="Microsoft YaHei"/>
+              </a:rPr>
               <a:t>实验画面</a:t>
             </a:r>
           </a:p>
@@ -5398,6 +5482,10 @@
               </a:defRPr>
             </a:pPr>
             <a:r>
+              <a:rPr>
+                <a:ea typeface="Microsoft YaHei"/>
+                <a:cs typeface="Microsoft YaHei"/>
+              </a:rPr>
               <a:t>部件与观测</a:t>
             </a:r>
           </a:p>
@@ -5434,6 +5522,10 @@
               </a:defRPr>
             </a:pPr>
             <a:r>
+              <a:rPr>
+                <a:ea typeface="Microsoft YaHei"/>
+                <a:cs typeface="Microsoft YaHei"/>
+              </a:rPr>
               <a:t>说明对应图中的具体对象。</a:t>
             </a:r>
           </a:p>
@@ -5470,6 +5562,10 @@
               </a:defRPr>
             </a:pPr>
             <a:r>
+              <a:rPr>
+                <a:ea typeface="Microsoft YaHei"/>
+                <a:cs typeface="Microsoft YaHei"/>
+              </a:rPr>
               <a:t>实验结果</a:t>
             </a:r>
           </a:p>
@@ -5506,6 +5602,10 @@
               </a:defRPr>
             </a:pPr>
             <a:r>
+              <a:rPr>
+                <a:ea typeface="Microsoft YaHei"/>
+                <a:cs typeface="Microsoft YaHei"/>
+              </a:rPr>
               <a:t>短句说明条件与结论。</a:t>
             </a:r>
           </a:p>
@@ -5560,6 +5660,10 @@
               </a:defRPr>
             </a:pPr>
             <a:r>
+              <a:rPr>
+                <a:ea typeface="Microsoft YaHei"/>
+                <a:cs typeface="Microsoft YaHei"/>
+              </a:rPr>
               <a:t>视频画面与色签</a:t>
             </a:r>
           </a:p>
@@ -5596,6 +5700,10 @@
               </a:defRPr>
             </a:pPr>
             <a:r>
+              <a:rPr>
+                <a:ea typeface="Microsoft YaHei"/>
+                <a:cs typeface="Microsoft YaHei"/>
+              </a:rPr>
               <a:t>色签在画面外侧，避免遮住工件、手指和实验数据。</a:t>
             </a:r>
           </a:p>
@@ -5675,6 +5783,10 @@
               </a:defRPr>
             </a:pPr>
             <a:r>
+              <a:rPr>
+                <a:ea typeface="Microsoft YaHei"/>
+                <a:cs typeface="Microsoft YaHei"/>
+              </a:rPr>
               <a:t>视频区域（此附件不含媒体）</a:t>
             </a:r>
           </a:p>
@@ -5756,6 +5868,10 @@
               </a:defRPr>
             </a:pPr>
             <a:r>
+              <a:rPr>
+                <a:ea typeface="Microsoft YaHei"/>
+                <a:cs typeface="Microsoft YaHei"/>
+              </a:rPr>
               <a:t>任务与接触过程</a:t>
             </a:r>
           </a:p>
@@ -5810,6 +5926,10 @@
               </a:defRPr>
             </a:pPr>
             <a:r>
+              <a:rPr>
+                <a:ea typeface="Microsoft YaHei"/>
+                <a:cs typeface="Microsoft YaHei"/>
+              </a:rPr>
               <a:t>部件、过程与系统</a:t>
             </a:r>
           </a:p>
@@ -5846,6 +5966,10 @@
               </a:defRPr>
             </a:pPr>
             <a:r>
+              <a:rPr>
+                <a:ea typeface="Microsoft YaHei"/>
+                <a:cs typeface="Microsoft YaHei"/>
+              </a:rPr>
               <a:t>箭头只表达真实先后或连接；并列内容不强画流程。</a:t>
             </a:r>
           </a:p>
@@ -5925,6 +6049,10 @@
               </a:defRPr>
             </a:pPr>
             <a:r>
+              <a:rPr>
+                <a:ea typeface="Microsoft YaHei"/>
+                <a:cs typeface="Microsoft YaHei"/>
+              </a:rPr>
               <a:t>器件</a:t>
             </a:r>
           </a:p>
@@ -5961,6 +6089,10 @@
               </a:defRPr>
             </a:pPr>
             <a:r>
+              <a:rPr>
+                <a:ea typeface="Microsoft YaHei"/>
+                <a:cs typeface="Microsoft YaHei"/>
+              </a:rPr>
               <a:t>器件</a:t>
             </a:r>
           </a:p>
@@ -6083,6 +6215,10 @@
               </a:defRPr>
             </a:pPr>
             <a:r>
+              <a:rPr>
+                <a:ea typeface="Microsoft YaHei"/>
+                <a:cs typeface="Microsoft YaHei"/>
+              </a:rPr>
               <a:t>接触过程</a:t>
             </a:r>
           </a:p>
@@ -6119,6 +6255,10 @@
               </a:defRPr>
             </a:pPr>
             <a:r>
+              <a:rPr>
+                <a:ea typeface="Microsoft YaHei"/>
+                <a:cs typeface="Microsoft YaHei"/>
+              </a:rPr>
               <a:t>接触过程</a:t>
             </a:r>
           </a:p>
@@ -6241,6 +6381,10 @@
               </a:defRPr>
             </a:pPr>
             <a:r>
+              <a:rPr>
+                <a:ea typeface="Microsoft YaHei"/>
+                <a:cs typeface="Microsoft YaHei"/>
+              </a:rPr>
               <a:t>系统观测</a:t>
             </a:r>
           </a:p>
@@ -6277,6 +6421,10 @@
               </a:defRPr>
             </a:pPr>
             <a:r>
+              <a:rPr>
+                <a:ea typeface="Microsoft YaHei"/>
+                <a:cs typeface="Microsoft YaHei"/>
+              </a:rPr>
               <a:t>系统观测</a:t>
             </a:r>
           </a:p>

</xml_diff>